<commit_message>
v9.2: remove 5,268 fluke peak from all slides, fix PPTX blank space
- Removed 5,268/d KPI tile, proven-peak chart line, and all text references
- KPI row now 3 tiles (capacity, tech cost, old software risk) — wider, no gaps
- Chart shows only the engineered 3,120/day sustainable line (y-max 4,000)
- PPTX Slide 2 redesigned: left column = modernization list, right column =
  pick accuracy panel (98.2%) with callout — no blank space
- Callout text simplified: "61,503 shipments" without peak reference

Co-Authored-By: Claude Opus 4.6 (1M context) <noreply@anthropic.com>
</commit_message>
<xml_diff>
--- a/brand.pptx
+++ b/brand.pptx
@@ -5447,7 +5447,7 @@
         <p:spPr>
           <a:xfrm>
             <a:off x="548640" y="1508760"/>
-            <a:ext cx="2651760" cy="25400"/>
+            <a:ext cx="3520440" cy="25400"/>
           </a:xfrm>
           <a:prstGeom prst="rect">
             <a:avLst/>
@@ -5490,7 +5490,7 @@
         <p:spPr>
           <a:xfrm>
             <a:off x="548640" y="1600200"/>
-            <a:ext cx="2651760" cy="457200"/>
+            <a:ext cx="3520440" cy="457200"/>
           </a:xfrm>
           <a:prstGeom prst="rect">
             <a:avLst/>
@@ -5523,7 +5523,7 @@
         <p:spPr>
           <a:xfrm>
             <a:off x="548640" y="2011680"/>
-            <a:ext cx="2651760" cy="365760"/>
+            <a:ext cx="3520440" cy="365760"/>
           </a:xfrm>
           <a:prstGeom prst="rect">
             <a:avLst/>
@@ -5556,8 +5556,8 @@
         </p:nvSpPr>
         <p:spPr>
           <a:xfrm>
-            <a:off x="3383280" y="1508760"/>
-            <a:ext cx="2651760" cy="25400"/>
+            <a:off x="4297679" y="1508760"/>
+            <a:ext cx="3520440" cy="25400"/>
           </a:xfrm>
           <a:prstGeom prst="rect">
             <a:avLst/>
@@ -5599,8 +5599,8 @@
         </p:nvSpPr>
         <p:spPr>
           <a:xfrm>
-            <a:off x="3383280" y="1600200"/>
-            <a:ext cx="2651760" cy="457200"/>
+            <a:off x="4297679" y="1600200"/>
+            <a:ext cx="3520440" cy="457200"/>
           </a:xfrm>
           <a:prstGeom prst="rect">
             <a:avLst/>
@@ -5619,7 +5619,7 @@
                 </a:solidFill>
                 <a:latin typeface="Georgia"/>
               </a:rPr>
-              <a:t>5,268/d</a:t>
+              <a:t>−50%</a:t>
             </a:r>
           </a:p>
         </p:txBody>
@@ -5632,8 +5632,8 @@
         </p:nvSpPr>
         <p:spPr>
           <a:xfrm>
-            <a:off x="3383280" y="2011680"/>
-            <a:ext cx="2651760" cy="365760"/>
+            <a:off x="4297679" y="2011680"/>
+            <a:ext cx="3520440" cy="365760"/>
           </a:xfrm>
           <a:prstGeom prst="rect">
             <a:avLst/>
@@ -5652,8 +5652,8 @@
                 </a:solidFill>
                 <a:latin typeface="Calibri"/>
               </a:rPr>
-              <a:t>SINGLE-DAY PEAK
-PROVEN · DEC 2025</a:t>
+              <a:t>TECHNOLOGY COST
+YEAR OVER YEAR</a:t>
             </a:r>
           </a:p>
         </p:txBody>
@@ -5666,8 +5666,8 @@
         </p:nvSpPr>
         <p:spPr>
           <a:xfrm>
-            <a:off x="6217920" y="1508760"/>
-            <a:ext cx="2651760" cy="25400"/>
+            <a:off x="8046718" y="1508760"/>
+            <a:ext cx="3520440" cy="25400"/>
           </a:xfrm>
           <a:prstGeom prst="rect">
             <a:avLst/>
@@ -5709,8 +5709,8 @@
         </p:nvSpPr>
         <p:spPr>
           <a:xfrm>
-            <a:off x="6217920" y="1600200"/>
-            <a:ext cx="2651760" cy="457200"/>
+            <a:off x="8046718" y="1600200"/>
+            <a:ext cx="3520440" cy="457200"/>
           </a:xfrm>
           <a:prstGeom prst="rect">
             <a:avLst/>
@@ -5729,7 +5729,7 @@
                 </a:solidFill>
                 <a:latin typeface="Georgia"/>
               </a:rPr>
-              <a:t>−50%</a:t>
+              <a:t>−75%</a:t>
             </a:r>
           </a:p>
         </p:txBody>
@@ -5742,8 +5742,8 @@
         </p:nvSpPr>
         <p:spPr>
           <a:xfrm>
-            <a:off x="6217920" y="2011680"/>
-            <a:ext cx="2651760" cy="365760"/>
+            <a:off x="8046718" y="2011680"/>
+            <a:ext cx="3520440" cy="365760"/>
           </a:xfrm>
           <a:prstGeom prst="rect">
             <a:avLst/>
@@ -5762,31 +5762,759 @@
                 </a:solidFill>
                 <a:latin typeface="Calibri"/>
               </a:rPr>
-              <a:t>TECHNOLOGY COST
-YEAR OVER YEAR</a:t>
-            </a:r>
-          </a:p>
-        </p:txBody>
-      </p:sp>
-      <p:sp>
-        <p:nvSpPr>
-          <p:cNvPr id="15" name="Rectangle 14"/>
+              <a:t>OLD SOFTWARE RISK
+ELIMINATED</a:t>
+            </a:r>
+          </a:p>
+        </p:txBody>
+      </p:sp>
+      <p:sp>
+        <p:nvSpPr>
+          <p:cNvPr id="15" name="TextBox 14"/>
+          <p:cNvSpPr txBox="1"/>
+          <p:nvPr/>
+        </p:nvSpPr>
+        <p:spPr>
+          <a:xfrm>
+            <a:off x="548640" y="2606040"/>
+            <a:ext cx="4572000" cy="228600"/>
+          </a:xfrm>
+          <a:prstGeom prst="rect">
+            <a:avLst/>
+          </a:prstGeom>
+          <a:noFill/>
+        </p:spPr>
+        <p:txBody>
+          <a:bodyPr wrap="square" anchor="t"/>
+          <a:lstStyle/>
+          <a:p>
+            <a:pPr algn="l"/>
+            <a:r>
+              <a:rPr sz="900" b="1" i="0">
+                <a:solidFill>
+                  <a:srgbClr val="3D1152"/>
+                </a:solidFill>
+                <a:latin typeface="Calibri"/>
+              </a:rPr>
+              <a:t>WHAT THE MODERNIZATION DELIVERED</a:t>
+            </a:r>
+          </a:p>
+        </p:txBody>
+      </p:sp>
+      <p:sp>
+        <p:nvSpPr>
+          <p:cNvPr id="16" name="TextBox 15"/>
+          <p:cNvSpPr txBox="1"/>
+          <p:nvPr/>
+        </p:nvSpPr>
+        <p:spPr>
+          <a:xfrm>
+            <a:off x="548640" y="2880360"/>
+            <a:ext cx="914400" cy="201168"/>
+          </a:xfrm>
+          <a:prstGeom prst="rect">
+            <a:avLst/>
+          </a:prstGeom>
+          <a:noFill/>
+        </p:spPr>
+        <p:txBody>
+          <a:bodyPr wrap="square" anchor="t"/>
+          <a:lstStyle/>
+          <a:p>
+            <a:pPr algn="l"/>
+            <a:r>
+              <a:rPr sz="800" b="1" i="0">
+                <a:solidFill>
+                  <a:srgbClr val="A5A5A5"/>
+                </a:solidFill>
+                <a:latin typeface="Calibri"/>
+              </a:rPr>
+              <a:t>MRP</a:t>
+            </a:r>
+          </a:p>
+        </p:txBody>
+      </p:sp>
+      <p:sp>
+        <p:nvSpPr>
+          <p:cNvPr id="17" name="TextBox 16"/>
+          <p:cNvSpPr txBox="1"/>
+          <p:nvPr/>
+        </p:nvSpPr>
+        <p:spPr>
+          <a:xfrm>
+            <a:off x="1554480" y="2880360"/>
+            <a:ext cx="3840480" cy="201168"/>
+          </a:xfrm>
+          <a:prstGeom prst="rect">
+            <a:avLst/>
+          </a:prstGeom>
+          <a:noFill/>
+        </p:spPr>
+        <p:txBody>
+          <a:bodyPr wrap="square" anchor="t"/>
+          <a:lstStyle/>
+          <a:p>
+            <a:pPr algn="l"/>
+            <a:r>
+              <a:rPr sz="1050" b="0" i="0">
+                <a:solidFill>
+                  <a:srgbClr val="242423"/>
+                </a:solidFill>
+                <a:latin typeface="Calibri"/>
+              </a:rPr>
+              <a:t>Retired the 15-year CMS; current-gen MRP in its place.</a:t>
+            </a:r>
+          </a:p>
+        </p:txBody>
+      </p:sp>
+      <p:sp>
+        <p:nvSpPr>
+          <p:cNvPr id="18" name="TextBox 17"/>
+          <p:cNvSpPr txBox="1"/>
+          <p:nvPr/>
+        </p:nvSpPr>
+        <p:spPr>
+          <a:xfrm>
+            <a:off x="5486400" y="2880360"/>
+            <a:ext cx="1097280" cy="201168"/>
+          </a:xfrm>
+          <a:prstGeom prst="rect">
+            <a:avLst/>
+          </a:prstGeom>
+          <a:noFill/>
+        </p:spPr>
+        <p:txBody>
+          <a:bodyPr wrap="square" anchor="t"/>
+          <a:lstStyle/>
+          <a:p>
+            <a:pPr algn="r"/>
+            <a:r>
+              <a:rPr sz="1050" b="0" i="1">
+                <a:solidFill>
+                  <a:srgbClr val="38165F"/>
+                </a:solidFill>
+                <a:latin typeface="Georgia"/>
+              </a:rPr>
+              <a:t>1 stack</a:t>
+            </a:r>
+          </a:p>
+        </p:txBody>
+      </p:sp>
+      <p:sp>
+        <p:nvSpPr>
+          <p:cNvPr id="19" name="TextBox 18"/>
+          <p:cNvSpPr txBox="1"/>
+          <p:nvPr/>
+        </p:nvSpPr>
+        <p:spPr>
+          <a:xfrm>
+            <a:off x="548640" y="3136392"/>
+            <a:ext cx="914400" cy="201168"/>
+          </a:xfrm>
+          <a:prstGeom prst="rect">
+            <a:avLst/>
+          </a:prstGeom>
+          <a:noFill/>
+        </p:spPr>
+        <p:txBody>
+          <a:bodyPr wrap="square" anchor="t"/>
+          <a:lstStyle/>
+          <a:p>
+            <a:pPr algn="l"/>
+            <a:r>
+              <a:rPr sz="800" b="1" i="0">
+                <a:solidFill>
+                  <a:srgbClr val="A5A5A5"/>
+                </a:solidFill>
+                <a:latin typeface="Calibri"/>
+              </a:rPr>
+              <a:t>RECIPE</a:t>
+            </a:r>
+          </a:p>
+        </p:txBody>
+      </p:sp>
+      <p:sp>
+        <p:nvSpPr>
+          <p:cNvPr id="20" name="TextBox 19"/>
+          <p:cNvSpPr txBox="1"/>
+          <p:nvPr/>
+        </p:nvSpPr>
+        <p:spPr>
+          <a:xfrm>
+            <a:off x="1554480" y="3136392"/>
+            <a:ext cx="3840480" cy="201168"/>
+          </a:xfrm>
+          <a:prstGeom prst="rect">
+            <a:avLst/>
+          </a:prstGeom>
+          <a:noFill/>
+        </p:spPr>
+        <p:txBody>
+          <a:bodyPr wrap="square" anchor="t"/>
+          <a:lstStyle/>
+          <a:p>
+            <a:pPr algn="l"/>
+            <a:r>
+              <a:rPr sz="1050" b="0" i="0">
+                <a:solidFill>
+                  <a:srgbClr val="242423"/>
+                </a:solidFill>
+                <a:latin typeface="Calibri"/>
+              </a:rPr>
+              <a:t>Flavor Studio replaces Nutracoster (20+ yrs) — AI at the bench.</a:t>
+            </a:r>
+          </a:p>
+        </p:txBody>
+      </p:sp>
+      <p:sp>
+        <p:nvSpPr>
+          <p:cNvPr id="21" name="TextBox 20"/>
+          <p:cNvSpPr txBox="1"/>
+          <p:nvPr/>
+        </p:nvSpPr>
+        <p:spPr>
+          <a:xfrm>
+            <a:off x="5486400" y="3136392"/>
+            <a:ext cx="1097280" cy="201168"/>
+          </a:xfrm>
+          <a:prstGeom prst="rect">
+            <a:avLst/>
+          </a:prstGeom>
+          <a:noFill/>
+        </p:spPr>
+        <p:txBody>
+          <a:bodyPr wrap="square" anchor="t"/>
+          <a:lstStyle/>
+          <a:p>
+            <a:pPr algn="r"/>
+            <a:r>
+              <a:rPr sz="1050" b="0" i="1">
+                <a:solidFill>
+                  <a:srgbClr val="38165F"/>
+                </a:solidFill>
+                <a:latin typeface="Georgia"/>
+              </a:rPr>
+              <a:t>Next-gen</a:t>
+            </a:r>
+          </a:p>
+        </p:txBody>
+      </p:sp>
+      <p:sp>
+        <p:nvSpPr>
+          <p:cNvPr id="22" name="TextBox 21"/>
+          <p:cNvSpPr txBox="1"/>
+          <p:nvPr/>
+        </p:nvSpPr>
+        <p:spPr>
+          <a:xfrm>
+            <a:off x="548640" y="3392424"/>
+            <a:ext cx="914400" cy="201168"/>
+          </a:xfrm>
+          <a:prstGeom prst="rect">
+            <a:avLst/>
+          </a:prstGeom>
+          <a:noFill/>
+        </p:spPr>
+        <p:txBody>
+          <a:bodyPr wrap="square" anchor="t"/>
+          <a:lstStyle/>
+          <a:p>
+            <a:pPr algn="l"/>
+            <a:r>
+              <a:rPr sz="800" b="1" i="0">
+                <a:solidFill>
+                  <a:srgbClr val="A5A5A5"/>
+                </a:solidFill>
+                <a:latin typeface="Calibri"/>
+              </a:rPr>
+              <a:t>FLOOR</a:t>
+            </a:r>
+          </a:p>
+        </p:txBody>
+      </p:sp>
+      <p:sp>
+        <p:nvSpPr>
+          <p:cNvPr id="23" name="TextBox 22"/>
+          <p:cNvSpPr txBox="1"/>
+          <p:nvPr/>
+        </p:nvSpPr>
+        <p:spPr>
+          <a:xfrm>
+            <a:off x="1554480" y="3392424"/>
+            <a:ext cx="3840480" cy="201168"/>
+          </a:xfrm>
+          <a:prstGeom prst="rect">
+            <a:avLst/>
+          </a:prstGeom>
+          <a:noFill/>
+        </p:spPr>
+        <p:txBody>
+          <a:bodyPr wrap="square" anchor="t"/>
+          <a:lstStyle/>
+          <a:p>
+            <a:pPr algn="l"/>
+            <a:r>
+              <a:rPr sz="1050" b="0" i="0">
+                <a:solidFill>
+                  <a:srgbClr val="242423"/>
+                </a:solidFill>
+                <a:latin typeface="Calibri"/>
+              </a:rPr>
+              <a:t>Tablets &amp; scanners at every station. Paper −50%.</a:t>
+            </a:r>
+          </a:p>
+        </p:txBody>
+      </p:sp>
+      <p:sp>
+        <p:nvSpPr>
+          <p:cNvPr id="24" name="TextBox 23"/>
+          <p:cNvSpPr txBox="1"/>
+          <p:nvPr/>
+        </p:nvSpPr>
+        <p:spPr>
+          <a:xfrm>
+            <a:off x="5486400" y="3392424"/>
+            <a:ext cx="1097280" cy="201168"/>
+          </a:xfrm>
+          <a:prstGeom prst="rect">
+            <a:avLst/>
+          </a:prstGeom>
+          <a:noFill/>
+        </p:spPr>
+        <p:txBody>
+          <a:bodyPr wrap="square" anchor="t"/>
+          <a:lstStyle/>
+          <a:p>
+            <a:pPr algn="r"/>
+            <a:r>
+              <a:rPr sz="1050" b="0" i="1">
+                <a:solidFill>
+                  <a:srgbClr val="38165F"/>
+                </a:solidFill>
+                <a:latin typeface="Georgia"/>
+              </a:rPr>
+              <a:t>Every station</a:t>
+            </a:r>
+          </a:p>
+        </p:txBody>
+      </p:sp>
+      <p:sp>
+        <p:nvSpPr>
+          <p:cNvPr id="25" name="TextBox 24"/>
+          <p:cNvSpPr txBox="1"/>
+          <p:nvPr/>
+        </p:nvSpPr>
+        <p:spPr>
+          <a:xfrm>
+            <a:off x="548640" y="3648456"/>
+            <a:ext cx="914400" cy="201168"/>
+          </a:xfrm>
+          <a:prstGeom prst="rect">
+            <a:avLst/>
+          </a:prstGeom>
+          <a:noFill/>
+        </p:spPr>
+        <p:txBody>
+          <a:bodyPr wrap="square" anchor="t"/>
+          <a:lstStyle/>
+          <a:p>
+            <a:pPr algn="l"/>
+            <a:r>
+              <a:rPr sz="800" b="1" i="0">
+                <a:solidFill>
+                  <a:srgbClr val="A5A5A5"/>
+                </a:solidFill>
+                <a:latin typeface="Calibri"/>
+              </a:rPr>
+              <a:t>SHIPPING</a:t>
+            </a:r>
+          </a:p>
+        </p:txBody>
+      </p:sp>
+      <p:sp>
+        <p:nvSpPr>
+          <p:cNvPr id="26" name="TextBox 25"/>
+          <p:cNvSpPr txBox="1"/>
+          <p:nvPr/>
+        </p:nvSpPr>
+        <p:spPr>
+          <a:xfrm>
+            <a:off x="1554480" y="3648456"/>
+            <a:ext cx="3840480" cy="201168"/>
+          </a:xfrm>
+          <a:prstGeom prst="rect">
+            <a:avLst/>
+          </a:prstGeom>
+          <a:noFill/>
+        </p:spPr>
+        <p:txBody>
+          <a:bodyPr wrap="square" anchor="t"/>
+          <a:lstStyle/>
+          <a:p>
+            <a:pPr algn="l"/>
+            <a:r>
+              <a:rPr sz="1050" b="0" i="0">
+                <a:solidFill>
+                  <a:srgbClr val="242423"/>
+                </a:solidFill>
+                <a:latin typeface="Calibri"/>
+              </a:rPr>
+              <a:t>Carrier simplification. Ice &amp; unboxing standardized.</a:t>
+            </a:r>
+          </a:p>
+        </p:txBody>
+      </p:sp>
+      <p:sp>
+        <p:nvSpPr>
+          <p:cNvPr id="27" name="TextBox 26"/>
+          <p:cNvSpPr txBox="1"/>
+          <p:nvPr/>
+        </p:nvSpPr>
+        <p:spPr>
+          <a:xfrm>
+            <a:off x="5486400" y="3648456"/>
+            <a:ext cx="1097280" cy="201168"/>
+          </a:xfrm>
+          <a:prstGeom prst="rect">
+            <a:avLst/>
+          </a:prstGeom>
+          <a:noFill/>
+        </p:spPr>
+        <p:txBody>
+          <a:bodyPr wrap="square" anchor="t"/>
+          <a:lstStyle/>
+          <a:p>
+            <a:pPr algn="r"/>
+            <a:r>
+              <a:rPr sz="1050" b="0" i="1">
+                <a:solidFill>
+                  <a:srgbClr val="38165F"/>
+                </a:solidFill>
+                <a:latin typeface="Georgia"/>
+              </a:rPr>
+              <a:t>−47% $/ship</a:t>
+            </a:r>
+          </a:p>
+        </p:txBody>
+      </p:sp>
+      <p:sp>
+        <p:nvSpPr>
+          <p:cNvPr id="28" name="TextBox 27"/>
+          <p:cNvSpPr txBox="1"/>
+          <p:nvPr/>
+        </p:nvSpPr>
+        <p:spPr>
+          <a:xfrm>
+            <a:off x="548640" y="3904488"/>
+            <a:ext cx="914400" cy="201168"/>
+          </a:xfrm>
+          <a:prstGeom prst="rect">
+            <a:avLst/>
+          </a:prstGeom>
+          <a:noFill/>
+        </p:spPr>
+        <p:txBody>
+          <a:bodyPr wrap="square" anchor="t"/>
+          <a:lstStyle/>
+          <a:p>
+            <a:pPr algn="l"/>
+            <a:r>
+              <a:rPr sz="800" b="1" i="0">
+                <a:solidFill>
+                  <a:srgbClr val="A5A5A5"/>
+                </a:solidFill>
+                <a:latin typeface="Calibri"/>
+              </a:rPr>
+              <a:t>SERVICE</a:t>
+            </a:r>
+          </a:p>
+        </p:txBody>
+      </p:sp>
+      <p:sp>
+        <p:nvSpPr>
+          <p:cNvPr id="29" name="TextBox 28"/>
+          <p:cNvSpPr txBox="1"/>
+          <p:nvPr/>
+        </p:nvSpPr>
+        <p:spPr>
+          <a:xfrm>
+            <a:off x="1554480" y="3904488"/>
+            <a:ext cx="3840480" cy="201168"/>
+          </a:xfrm>
+          <a:prstGeom prst="rect">
+            <a:avLst/>
+          </a:prstGeom>
+          <a:noFill/>
+        </p:spPr>
+        <p:txBody>
+          <a:bodyPr wrap="square" anchor="t"/>
+          <a:lstStyle/>
+          <a:p>
+            <a:pPr algn="l"/>
+            <a:r>
+              <a:rPr sz="1050" b="0" i="0">
+                <a:solidFill>
+                  <a:srgbClr val="242423"/>
+                </a:solidFill>
+                <a:latin typeface="Calibri"/>
+              </a:rPr>
+              <a:t>Gorgias + 24/7 agents — answered under the hour.</a:t>
+            </a:r>
+          </a:p>
+        </p:txBody>
+      </p:sp>
+      <p:sp>
+        <p:nvSpPr>
+          <p:cNvPr id="30" name="TextBox 29"/>
+          <p:cNvSpPr txBox="1"/>
+          <p:nvPr/>
+        </p:nvSpPr>
+        <p:spPr>
+          <a:xfrm>
+            <a:off x="5486400" y="3904488"/>
+            <a:ext cx="1097280" cy="201168"/>
+          </a:xfrm>
+          <a:prstGeom prst="rect">
+            <a:avLst/>
+          </a:prstGeom>
+          <a:noFill/>
+        </p:spPr>
+        <p:txBody>
+          <a:bodyPr wrap="square" anchor="t"/>
+          <a:lstStyle/>
+          <a:p>
+            <a:pPr algn="r"/>
+            <a:r>
+              <a:rPr sz="1050" b="0" i="1">
+                <a:solidFill>
+                  <a:srgbClr val="38165F"/>
+                </a:solidFill>
+                <a:latin typeface="Georgia"/>
+              </a:rPr>
+              <a:t>24–48h → 1h</a:t>
+            </a:r>
+          </a:p>
+        </p:txBody>
+      </p:sp>
+      <p:sp>
+        <p:nvSpPr>
+          <p:cNvPr id="31" name="TextBox 30"/>
+          <p:cNvSpPr txBox="1"/>
+          <p:nvPr/>
+        </p:nvSpPr>
+        <p:spPr>
+          <a:xfrm>
+            <a:off x="548640" y="4160520"/>
+            <a:ext cx="914400" cy="201168"/>
+          </a:xfrm>
+          <a:prstGeom prst="rect">
+            <a:avLst/>
+          </a:prstGeom>
+          <a:noFill/>
+        </p:spPr>
+        <p:txBody>
+          <a:bodyPr wrap="square" anchor="t"/>
+          <a:lstStyle/>
+          <a:p>
+            <a:pPr algn="l"/>
+            <a:r>
+              <a:rPr sz="800" b="1" i="0">
+                <a:solidFill>
+                  <a:srgbClr val="A5A5A5"/>
+                </a:solidFill>
+                <a:latin typeface="Calibri"/>
+              </a:rPr>
+              <a:t>VISIBILITY</a:t>
+            </a:r>
+          </a:p>
+        </p:txBody>
+      </p:sp>
+      <p:sp>
+        <p:nvSpPr>
+          <p:cNvPr id="32" name="TextBox 31"/>
+          <p:cNvSpPr txBox="1"/>
+          <p:nvPr/>
+        </p:nvSpPr>
+        <p:spPr>
+          <a:xfrm>
+            <a:off x="1554480" y="4160520"/>
+            <a:ext cx="3840480" cy="201168"/>
+          </a:xfrm>
+          <a:prstGeom prst="rect">
+            <a:avLst/>
+          </a:prstGeom>
+          <a:noFill/>
+        </p:spPr>
+        <p:txBody>
+          <a:bodyPr wrap="square" anchor="t"/>
+          <a:lstStyle/>
+          <a:p>
+            <a:pPr algn="l"/>
+            <a:r>
+              <a:rPr sz="1050" b="0" i="0">
+                <a:solidFill>
+                  <a:srgbClr val="242423"/>
+                </a:solidFill>
+                <a:latin typeface="Calibri"/>
+              </a:rPr>
+              <a:t>Live dashboards. 24/7 automated audits. Data-driven decisions.</a:t>
+            </a:r>
+          </a:p>
+        </p:txBody>
+      </p:sp>
+      <p:sp>
+        <p:nvSpPr>
+          <p:cNvPr id="33" name="TextBox 32"/>
+          <p:cNvSpPr txBox="1"/>
+          <p:nvPr/>
+        </p:nvSpPr>
+        <p:spPr>
+          <a:xfrm>
+            <a:off x="5486400" y="4160520"/>
+            <a:ext cx="1097280" cy="201168"/>
+          </a:xfrm>
+          <a:prstGeom prst="rect">
+            <a:avLst/>
+          </a:prstGeom>
+          <a:noFill/>
+        </p:spPr>
+        <p:txBody>
+          <a:bodyPr wrap="square" anchor="t"/>
+          <a:lstStyle/>
+          <a:p>
+            <a:pPr algn="r"/>
+            <a:r>
+              <a:rPr sz="1050" b="0" i="1">
+                <a:solidFill>
+                  <a:srgbClr val="38165F"/>
+                </a:solidFill>
+                <a:latin typeface="Georgia"/>
+              </a:rPr>
+              <a:t>Always-on</a:t>
+            </a:r>
+          </a:p>
+        </p:txBody>
+      </p:sp>
+      <p:sp>
+        <p:nvSpPr>
+          <p:cNvPr id="34" name="TextBox 33"/>
+          <p:cNvSpPr txBox="1"/>
+          <p:nvPr/>
+        </p:nvSpPr>
+        <p:spPr>
+          <a:xfrm>
+            <a:off x="548640" y="4416552"/>
+            <a:ext cx="914400" cy="201168"/>
+          </a:xfrm>
+          <a:prstGeom prst="rect">
+            <a:avLst/>
+          </a:prstGeom>
+          <a:noFill/>
+        </p:spPr>
+        <p:txBody>
+          <a:bodyPr wrap="square" anchor="t"/>
+          <a:lstStyle/>
+          <a:p>
+            <a:pPr algn="l"/>
+            <a:r>
+              <a:rPr sz="800" b="1" i="0">
+                <a:solidFill>
+                  <a:srgbClr val="A5A5A5"/>
+                </a:solidFill>
+                <a:latin typeface="Calibri"/>
+              </a:rPr>
+              <a:t>INTEGRATION</a:t>
+            </a:r>
+          </a:p>
+        </p:txBody>
+      </p:sp>
+      <p:sp>
+        <p:nvSpPr>
+          <p:cNvPr id="35" name="TextBox 34"/>
+          <p:cNvSpPr txBox="1"/>
+          <p:nvPr/>
+        </p:nvSpPr>
+        <p:spPr>
+          <a:xfrm>
+            <a:off x="1554480" y="4416552"/>
+            <a:ext cx="3840480" cy="201168"/>
+          </a:xfrm>
+          <a:prstGeom prst="rect">
+            <a:avLst/>
+          </a:prstGeom>
+          <a:noFill/>
+        </p:spPr>
+        <p:txBody>
+          <a:bodyPr wrap="square" anchor="t"/>
+          <a:lstStyle/>
+          <a:p>
+            <a:pPr algn="l"/>
+            <a:r>
+              <a:rPr sz="1050" b="0" i="0">
+                <a:solidFill>
+                  <a:srgbClr val="242423"/>
+                </a:solidFill>
+                <a:latin typeface="Calibri"/>
+              </a:rPr>
+              <a:t>Every system talks to every other system.</a:t>
+            </a:r>
+          </a:p>
+        </p:txBody>
+      </p:sp>
+      <p:sp>
+        <p:nvSpPr>
+          <p:cNvPr id="36" name="TextBox 35"/>
+          <p:cNvSpPr txBox="1"/>
+          <p:nvPr/>
+        </p:nvSpPr>
+        <p:spPr>
+          <a:xfrm>
+            <a:off x="5486400" y="4416552"/>
+            <a:ext cx="1097280" cy="201168"/>
+          </a:xfrm>
+          <a:prstGeom prst="rect">
+            <a:avLst/>
+          </a:prstGeom>
+          <a:noFill/>
+        </p:spPr>
+        <p:txBody>
+          <a:bodyPr wrap="square" anchor="t"/>
+          <a:lstStyle/>
+          <a:p>
+            <a:pPr algn="r"/>
+            <a:r>
+              <a:rPr sz="1050" b="0" i="1">
+                <a:solidFill>
+                  <a:srgbClr val="38165F"/>
+                </a:solidFill>
+                <a:latin typeface="Georgia"/>
+              </a:rPr>
+              <a:t>One graph</a:t>
+            </a:r>
+          </a:p>
+        </p:txBody>
+      </p:sp>
+      <p:sp>
+        <p:nvSpPr>
+          <p:cNvPr id="37" name="Rectangle 36"/>
           <p:cNvSpPr/>
           <p:nvPr/>
         </p:nvSpPr>
         <p:spPr>
           <a:xfrm>
-            <a:off x="9052560" y="1508760"/>
-            <a:ext cx="2651760" cy="25400"/>
+            <a:off x="7132320" y="2606040"/>
+            <a:ext cx="4572000" cy="3840480"/>
           </a:xfrm>
           <a:prstGeom prst="rect">
             <a:avLst/>
           </a:prstGeom>
           <a:solidFill>
-            <a:srgbClr val="38165F"/>
+            <a:srgbClr val="F6F6F4"/>
           </a:solidFill>
-          <a:ln>
-            <a:noFill/>
+          <a:ln w="9525">
+            <a:solidFill>
+              <a:srgbClr val="D9D3CB"/>
+            </a:solidFill>
           </a:ln>
         </p:spPr>
         <p:style>
@@ -5813,760 +6541,33 @@
       </p:sp>
       <p:sp>
         <p:nvSpPr>
-          <p:cNvPr id="16" name="TextBox 15"/>
-          <p:cNvSpPr txBox="1"/>
-          <p:nvPr/>
-        </p:nvSpPr>
-        <p:spPr>
-          <a:xfrm>
-            <a:off x="9052560" y="1600200"/>
-            <a:ext cx="2651760" cy="457200"/>
-          </a:xfrm>
-          <a:prstGeom prst="rect">
-            <a:avLst/>
-          </a:prstGeom>
-          <a:noFill/>
-        </p:spPr>
-        <p:txBody>
-          <a:bodyPr wrap="square" anchor="t"/>
-          <a:lstStyle/>
-          <a:p>
-            <a:pPr algn="l"/>
-            <a:r>
-              <a:rPr sz="2800" b="0" i="0">
-                <a:solidFill>
-                  <a:srgbClr val="38165F"/>
-                </a:solidFill>
-                <a:latin typeface="Georgia"/>
-              </a:rPr>
-              <a:t>−75%</a:t>
-            </a:r>
-          </a:p>
-        </p:txBody>
-      </p:sp>
-      <p:sp>
-        <p:nvSpPr>
-          <p:cNvPr id="17" name="TextBox 16"/>
-          <p:cNvSpPr txBox="1"/>
-          <p:nvPr/>
-        </p:nvSpPr>
-        <p:spPr>
-          <a:xfrm>
-            <a:off x="9052560" y="2011680"/>
-            <a:ext cx="2651760" cy="365760"/>
-          </a:xfrm>
-          <a:prstGeom prst="rect">
-            <a:avLst/>
-          </a:prstGeom>
-          <a:noFill/>
-        </p:spPr>
-        <p:txBody>
-          <a:bodyPr wrap="square" anchor="t"/>
-          <a:lstStyle/>
-          <a:p>
-            <a:pPr algn="l"/>
-            <a:r>
-              <a:rPr sz="800" b="1" i="0">
+          <p:cNvPr id="38" name="TextBox 37"/>
+          <p:cNvSpPr txBox="1"/>
+          <p:nvPr/>
+        </p:nvSpPr>
+        <p:spPr>
+          <a:xfrm>
+            <a:off x="7406640" y="2743200"/>
+            <a:ext cx="4023360" cy="182880"/>
+          </a:xfrm>
+          <a:prstGeom prst="rect">
+            <a:avLst/>
+          </a:prstGeom>
+          <a:noFill/>
+        </p:spPr>
+        <p:txBody>
+          <a:bodyPr wrap="square" anchor="t"/>
+          <a:lstStyle/>
+          <a:p>
+            <a:pPr algn="l"/>
+            <a:r>
+              <a:rPr sz="900" b="1" i="0">
                 <a:solidFill>
                   <a:srgbClr val="A5A5A5"/>
                 </a:solidFill>
                 <a:latin typeface="Calibri"/>
               </a:rPr>
-              <a:t>OLD SOFTWARE RISK
-ELIMINATED</a:t>
-            </a:r>
-          </a:p>
-        </p:txBody>
-      </p:sp>
-      <p:sp>
-        <p:nvSpPr>
-          <p:cNvPr id="18" name="TextBox 17"/>
-          <p:cNvSpPr txBox="1"/>
-          <p:nvPr/>
-        </p:nvSpPr>
-        <p:spPr>
-          <a:xfrm>
-            <a:off x="548640" y="2606040"/>
-            <a:ext cx="4572000" cy="228600"/>
-          </a:xfrm>
-          <a:prstGeom prst="rect">
-            <a:avLst/>
-          </a:prstGeom>
-          <a:noFill/>
-        </p:spPr>
-        <p:txBody>
-          <a:bodyPr wrap="square" anchor="t"/>
-          <a:lstStyle/>
-          <a:p>
-            <a:pPr algn="l"/>
-            <a:r>
-              <a:rPr sz="900" b="1" i="0">
-                <a:solidFill>
-                  <a:srgbClr val="3D1152"/>
-                </a:solidFill>
-                <a:latin typeface="Calibri"/>
-              </a:rPr>
-              <a:t>WHAT THE MODERNIZATION DELIVERED</a:t>
-            </a:r>
-          </a:p>
-        </p:txBody>
-      </p:sp>
-      <p:sp>
-        <p:nvSpPr>
-          <p:cNvPr id="19" name="TextBox 18"/>
-          <p:cNvSpPr txBox="1"/>
-          <p:nvPr/>
-        </p:nvSpPr>
-        <p:spPr>
-          <a:xfrm>
-            <a:off x="548640" y="2880360"/>
-            <a:ext cx="914400" cy="201168"/>
-          </a:xfrm>
-          <a:prstGeom prst="rect">
-            <a:avLst/>
-          </a:prstGeom>
-          <a:noFill/>
-        </p:spPr>
-        <p:txBody>
-          <a:bodyPr wrap="square" anchor="t"/>
-          <a:lstStyle/>
-          <a:p>
-            <a:pPr algn="l"/>
-            <a:r>
-              <a:rPr sz="800" b="1" i="0">
-                <a:solidFill>
-                  <a:srgbClr val="A5A5A5"/>
-                </a:solidFill>
-                <a:latin typeface="Calibri"/>
-              </a:rPr>
-              <a:t>MRP</a:t>
-            </a:r>
-          </a:p>
-        </p:txBody>
-      </p:sp>
-      <p:sp>
-        <p:nvSpPr>
-          <p:cNvPr id="20" name="TextBox 19"/>
-          <p:cNvSpPr txBox="1"/>
-          <p:nvPr/>
-        </p:nvSpPr>
-        <p:spPr>
-          <a:xfrm>
-            <a:off x="1554480" y="2880360"/>
-            <a:ext cx="4572000" cy="201168"/>
-          </a:xfrm>
-          <a:prstGeom prst="rect">
-            <a:avLst/>
-          </a:prstGeom>
-          <a:noFill/>
-        </p:spPr>
-        <p:txBody>
-          <a:bodyPr wrap="square" anchor="t"/>
-          <a:lstStyle/>
-          <a:p>
-            <a:pPr algn="l"/>
-            <a:r>
-              <a:rPr sz="1050" b="0" i="0">
-                <a:solidFill>
-                  <a:srgbClr val="242423"/>
-                </a:solidFill>
-                <a:latin typeface="Calibri"/>
-              </a:rPr>
-              <a:t>Retired the 15-year CMS; current-gen MRP in its place.</a:t>
-            </a:r>
-          </a:p>
-        </p:txBody>
-      </p:sp>
-      <p:sp>
-        <p:nvSpPr>
-          <p:cNvPr id="21" name="TextBox 20"/>
-          <p:cNvSpPr txBox="1"/>
-          <p:nvPr/>
-        </p:nvSpPr>
-        <p:spPr>
-          <a:xfrm>
-            <a:off x="6400800" y="2880360"/>
-            <a:ext cx="1097280" cy="201168"/>
-          </a:xfrm>
-          <a:prstGeom prst="rect">
-            <a:avLst/>
-          </a:prstGeom>
-          <a:noFill/>
-        </p:spPr>
-        <p:txBody>
-          <a:bodyPr wrap="square" anchor="t"/>
-          <a:lstStyle/>
-          <a:p>
-            <a:pPr algn="r"/>
-            <a:r>
-              <a:rPr sz="1050" b="0" i="1">
-                <a:solidFill>
-                  <a:srgbClr val="38165F"/>
-                </a:solidFill>
-                <a:latin typeface="Georgia"/>
-              </a:rPr>
-              <a:t>1 stack</a:t>
-            </a:r>
-          </a:p>
-        </p:txBody>
-      </p:sp>
-      <p:sp>
-        <p:nvSpPr>
-          <p:cNvPr id="22" name="TextBox 21"/>
-          <p:cNvSpPr txBox="1"/>
-          <p:nvPr/>
-        </p:nvSpPr>
-        <p:spPr>
-          <a:xfrm>
-            <a:off x="548640" y="3136392"/>
-            <a:ext cx="914400" cy="201168"/>
-          </a:xfrm>
-          <a:prstGeom prst="rect">
-            <a:avLst/>
-          </a:prstGeom>
-          <a:noFill/>
-        </p:spPr>
-        <p:txBody>
-          <a:bodyPr wrap="square" anchor="t"/>
-          <a:lstStyle/>
-          <a:p>
-            <a:pPr algn="l"/>
-            <a:r>
-              <a:rPr sz="800" b="1" i="0">
-                <a:solidFill>
-                  <a:srgbClr val="A5A5A5"/>
-                </a:solidFill>
-                <a:latin typeface="Calibri"/>
-              </a:rPr>
-              <a:t>RECIPE</a:t>
-            </a:r>
-          </a:p>
-        </p:txBody>
-      </p:sp>
-      <p:sp>
-        <p:nvSpPr>
-          <p:cNvPr id="23" name="TextBox 22"/>
-          <p:cNvSpPr txBox="1"/>
-          <p:nvPr/>
-        </p:nvSpPr>
-        <p:spPr>
-          <a:xfrm>
-            <a:off x="1554480" y="3136392"/>
-            <a:ext cx="4572000" cy="201168"/>
-          </a:xfrm>
-          <a:prstGeom prst="rect">
-            <a:avLst/>
-          </a:prstGeom>
-          <a:noFill/>
-        </p:spPr>
-        <p:txBody>
-          <a:bodyPr wrap="square" anchor="t"/>
-          <a:lstStyle/>
-          <a:p>
-            <a:pPr algn="l"/>
-            <a:r>
-              <a:rPr sz="1050" b="0" i="0">
-                <a:solidFill>
-                  <a:srgbClr val="242423"/>
-                </a:solidFill>
-                <a:latin typeface="Calibri"/>
-              </a:rPr>
-              <a:t>Flavor Studio replaces Nutracoster (20+ yrs) — AI at the bench.</a:t>
-            </a:r>
-          </a:p>
-        </p:txBody>
-      </p:sp>
-      <p:sp>
-        <p:nvSpPr>
-          <p:cNvPr id="24" name="TextBox 23"/>
-          <p:cNvSpPr txBox="1"/>
-          <p:nvPr/>
-        </p:nvSpPr>
-        <p:spPr>
-          <a:xfrm>
-            <a:off x="6400800" y="3136392"/>
-            <a:ext cx="1097280" cy="201168"/>
-          </a:xfrm>
-          <a:prstGeom prst="rect">
-            <a:avLst/>
-          </a:prstGeom>
-          <a:noFill/>
-        </p:spPr>
-        <p:txBody>
-          <a:bodyPr wrap="square" anchor="t"/>
-          <a:lstStyle/>
-          <a:p>
-            <a:pPr algn="r"/>
-            <a:r>
-              <a:rPr sz="1050" b="0" i="1">
-                <a:solidFill>
-                  <a:srgbClr val="38165F"/>
-                </a:solidFill>
-                <a:latin typeface="Georgia"/>
-              </a:rPr>
-              <a:t>Next-gen</a:t>
-            </a:r>
-          </a:p>
-        </p:txBody>
-      </p:sp>
-      <p:sp>
-        <p:nvSpPr>
-          <p:cNvPr id="25" name="TextBox 24"/>
-          <p:cNvSpPr txBox="1"/>
-          <p:nvPr/>
-        </p:nvSpPr>
-        <p:spPr>
-          <a:xfrm>
-            <a:off x="548640" y="3392424"/>
-            <a:ext cx="914400" cy="201168"/>
-          </a:xfrm>
-          <a:prstGeom prst="rect">
-            <a:avLst/>
-          </a:prstGeom>
-          <a:noFill/>
-        </p:spPr>
-        <p:txBody>
-          <a:bodyPr wrap="square" anchor="t"/>
-          <a:lstStyle/>
-          <a:p>
-            <a:pPr algn="l"/>
-            <a:r>
-              <a:rPr sz="800" b="1" i="0">
-                <a:solidFill>
-                  <a:srgbClr val="A5A5A5"/>
-                </a:solidFill>
-                <a:latin typeface="Calibri"/>
-              </a:rPr>
-              <a:t>FLOOR</a:t>
-            </a:r>
-          </a:p>
-        </p:txBody>
-      </p:sp>
-      <p:sp>
-        <p:nvSpPr>
-          <p:cNvPr id="26" name="TextBox 25"/>
-          <p:cNvSpPr txBox="1"/>
-          <p:nvPr/>
-        </p:nvSpPr>
-        <p:spPr>
-          <a:xfrm>
-            <a:off x="1554480" y="3392424"/>
-            <a:ext cx="4572000" cy="201168"/>
-          </a:xfrm>
-          <a:prstGeom prst="rect">
-            <a:avLst/>
-          </a:prstGeom>
-          <a:noFill/>
-        </p:spPr>
-        <p:txBody>
-          <a:bodyPr wrap="square" anchor="t"/>
-          <a:lstStyle/>
-          <a:p>
-            <a:pPr algn="l"/>
-            <a:r>
-              <a:rPr sz="1050" b="0" i="0">
-                <a:solidFill>
-                  <a:srgbClr val="242423"/>
-                </a:solidFill>
-                <a:latin typeface="Calibri"/>
-              </a:rPr>
-              <a:t>Tablets &amp; scanners at every station. Paper −50%.</a:t>
-            </a:r>
-          </a:p>
-        </p:txBody>
-      </p:sp>
-      <p:sp>
-        <p:nvSpPr>
-          <p:cNvPr id="27" name="TextBox 26"/>
-          <p:cNvSpPr txBox="1"/>
-          <p:nvPr/>
-        </p:nvSpPr>
-        <p:spPr>
-          <a:xfrm>
-            <a:off x="6400800" y="3392424"/>
-            <a:ext cx="1097280" cy="201168"/>
-          </a:xfrm>
-          <a:prstGeom prst="rect">
-            <a:avLst/>
-          </a:prstGeom>
-          <a:noFill/>
-        </p:spPr>
-        <p:txBody>
-          <a:bodyPr wrap="square" anchor="t"/>
-          <a:lstStyle/>
-          <a:p>
-            <a:pPr algn="r"/>
-            <a:r>
-              <a:rPr sz="1050" b="0" i="1">
-                <a:solidFill>
-                  <a:srgbClr val="38165F"/>
-                </a:solidFill>
-                <a:latin typeface="Georgia"/>
-              </a:rPr>
-              <a:t>Every station</a:t>
-            </a:r>
-          </a:p>
-        </p:txBody>
-      </p:sp>
-      <p:sp>
-        <p:nvSpPr>
-          <p:cNvPr id="28" name="TextBox 27"/>
-          <p:cNvSpPr txBox="1"/>
-          <p:nvPr/>
-        </p:nvSpPr>
-        <p:spPr>
-          <a:xfrm>
-            <a:off x="548640" y="3648456"/>
-            <a:ext cx="914400" cy="201168"/>
-          </a:xfrm>
-          <a:prstGeom prst="rect">
-            <a:avLst/>
-          </a:prstGeom>
-          <a:noFill/>
-        </p:spPr>
-        <p:txBody>
-          <a:bodyPr wrap="square" anchor="t"/>
-          <a:lstStyle/>
-          <a:p>
-            <a:pPr algn="l"/>
-            <a:r>
-              <a:rPr sz="800" b="1" i="0">
-                <a:solidFill>
-                  <a:srgbClr val="A5A5A5"/>
-                </a:solidFill>
-                <a:latin typeface="Calibri"/>
-              </a:rPr>
-              <a:t>SHIPPING</a:t>
-            </a:r>
-          </a:p>
-        </p:txBody>
-      </p:sp>
-      <p:sp>
-        <p:nvSpPr>
-          <p:cNvPr id="29" name="TextBox 28"/>
-          <p:cNvSpPr txBox="1"/>
-          <p:nvPr/>
-        </p:nvSpPr>
-        <p:spPr>
-          <a:xfrm>
-            <a:off x="1554480" y="3648456"/>
-            <a:ext cx="4572000" cy="201168"/>
-          </a:xfrm>
-          <a:prstGeom prst="rect">
-            <a:avLst/>
-          </a:prstGeom>
-          <a:noFill/>
-        </p:spPr>
-        <p:txBody>
-          <a:bodyPr wrap="square" anchor="t"/>
-          <a:lstStyle/>
-          <a:p>
-            <a:pPr algn="l"/>
-            <a:r>
-              <a:rPr sz="1050" b="0" i="0">
-                <a:solidFill>
-                  <a:srgbClr val="242423"/>
-                </a:solidFill>
-                <a:latin typeface="Calibri"/>
-              </a:rPr>
-              <a:t>Carrier simplification. Ice &amp; unboxing standardized.</a:t>
-            </a:r>
-          </a:p>
-        </p:txBody>
-      </p:sp>
-      <p:sp>
-        <p:nvSpPr>
-          <p:cNvPr id="30" name="TextBox 29"/>
-          <p:cNvSpPr txBox="1"/>
-          <p:nvPr/>
-        </p:nvSpPr>
-        <p:spPr>
-          <a:xfrm>
-            <a:off x="6400800" y="3648456"/>
-            <a:ext cx="1097280" cy="201168"/>
-          </a:xfrm>
-          <a:prstGeom prst="rect">
-            <a:avLst/>
-          </a:prstGeom>
-          <a:noFill/>
-        </p:spPr>
-        <p:txBody>
-          <a:bodyPr wrap="square" anchor="t"/>
-          <a:lstStyle/>
-          <a:p>
-            <a:pPr algn="r"/>
-            <a:r>
-              <a:rPr sz="1050" b="0" i="1">
-                <a:solidFill>
-                  <a:srgbClr val="38165F"/>
-                </a:solidFill>
-                <a:latin typeface="Georgia"/>
-              </a:rPr>
-              <a:t>−47% $/ship</a:t>
-            </a:r>
-          </a:p>
-        </p:txBody>
-      </p:sp>
-      <p:sp>
-        <p:nvSpPr>
-          <p:cNvPr id="31" name="TextBox 30"/>
-          <p:cNvSpPr txBox="1"/>
-          <p:nvPr/>
-        </p:nvSpPr>
-        <p:spPr>
-          <a:xfrm>
-            <a:off x="548640" y="3904488"/>
-            <a:ext cx="914400" cy="201168"/>
-          </a:xfrm>
-          <a:prstGeom prst="rect">
-            <a:avLst/>
-          </a:prstGeom>
-          <a:noFill/>
-        </p:spPr>
-        <p:txBody>
-          <a:bodyPr wrap="square" anchor="t"/>
-          <a:lstStyle/>
-          <a:p>
-            <a:pPr algn="l"/>
-            <a:r>
-              <a:rPr sz="800" b="1" i="0">
-                <a:solidFill>
-                  <a:srgbClr val="A5A5A5"/>
-                </a:solidFill>
-                <a:latin typeface="Calibri"/>
-              </a:rPr>
-              <a:t>SERVICE</a:t>
-            </a:r>
-          </a:p>
-        </p:txBody>
-      </p:sp>
-      <p:sp>
-        <p:nvSpPr>
-          <p:cNvPr id="32" name="TextBox 31"/>
-          <p:cNvSpPr txBox="1"/>
-          <p:nvPr/>
-        </p:nvSpPr>
-        <p:spPr>
-          <a:xfrm>
-            <a:off x="1554480" y="3904488"/>
-            <a:ext cx="4572000" cy="201168"/>
-          </a:xfrm>
-          <a:prstGeom prst="rect">
-            <a:avLst/>
-          </a:prstGeom>
-          <a:noFill/>
-        </p:spPr>
-        <p:txBody>
-          <a:bodyPr wrap="square" anchor="t"/>
-          <a:lstStyle/>
-          <a:p>
-            <a:pPr algn="l"/>
-            <a:r>
-              <a:rPr sz="1050" b="0" i="0">
-                <a:solidFill>
-                  <a:srgbClr val="242423"/>
-                </a:solidFill>
-                <a:latin typeface="Calibri"/>
-              </a:rPr>
-              <a:t>Gorgias + 24/7 agents — answered under the hour.</a:t>
-            </a:r>
-          </a:p>
-        </p:txBody>
-      </p:sp>
-      <p:sp>
-        <p:nvSpPr>
-          <p:cNvPr id="33" name="TextBox 32"/>
-          <p:cNvSpPr txBox="1"/>
-          <p:nvPr/>
-        </p:nvSpPr>
-        <p:spPr>
-          <a:xfrm>
-            <a:off x="6400800" y="3904488"/>
-            <a:ext cx="1097280" cy="201168"/>
-          </a:xfrm>
-          <a:prstGeom prst="rect">
-            <a:avLst/>
-          </a:prstGeom>
-          <a:noFill/>
-        </p:spPr>
-        <p:txBody>
-          <a:bodyPr wrap="square" anchor="t"/>
-          <a:lstStyle/>
-          <a:p>
-            <a:pPr algn="r"/>
-            <a:r>
-              <a:rPr sz="1050" b="0" i="1">
-                <a:solidFill>
-                  <a:srgbClr val="38165F"/>
-                </a:solidFill>
-                <a:latin typeface="Georgia"/>
-              </a:rPr>
-              <a:t>24–48h → 1h</a:t>
-            </a:r>
-          </a:p>
-        </p:txBody>
-      </p:sp>
-      <p:sp>
-        <p:nvSpPr>
-          <p:cNvPr id="34" name="TextBox 33"/>
-          <p:cNvSpPr txBox="1"/>
-          <p:nvPr/>
-        </p:nvSpPr>
-        <p:spPr>
-          <a:xfrm>
-            <a:off x="548640" y="4160520"/>
-            <a:ext cx="914400" cy="201168"/>
-          </a:xfrm>
-          <a:prstGeom prst="rect">
-            <a:avLst/>
-          </a:prstGeom>
-          <a:noFill/>
-        </p:spPr>
-        <p:txBody>
-          <a:bodyPr wrap="square" anchor="t"/>
-          <a:lstStyle/>
-          <a:p>
-            <a:pPr algn="l"/>
-            <a:r>
-              <a:rPr sz="800" b="1" i="0">
-                <a:solidFill>
-                  <a:srgbClr val="A5A5A5"/>
-                </a:solidFill>
-                <a:latin typeface="Calibri"/>
-              </a:rPr>
-              <a:t>VISIBILITY</a:t>
-            </a:r>
-          </a:p>
-        </p:txBody>
-      </p:sp>
-      <p:sp>
-        <p:nvSpPr>
-          <p:cNvPr id="35" name="TextBox 34"/>
-          <p:cNvSpPr txBox="1"/>
-          <p:nvPr/>
-        </p:nvSpPr>
-        <p:spPr>
-          <a:xfrm>
-            <a:off x="1554480" y="4160520"/>
-            <a:ext cx="4572000" cy="201168"/>
-          </a:xfrm>
-          <a:prstGeom prst="rect">
-            <a:avLst/>
-          </a:prstGeom>
-          <a:noFill/>
-        </p:spPr>
-        <p:txBody>
-          <a:bodyPr wrap="square" anchor="t"/>
-          <a:lstStyle/>
-          <a:p>
-            <a:pPr algn="l"/>
-            <a:r>
-              <a:rPr sz="1050" b="0" i="0">
-                <a:solidFill>
-                  <a:srgbClr val="242423"/>
-                </a:solidFill>
-                <a:latin typeface="Calibri"/>
-              </a:rPr>
-              <a:t>Live dashboards. 24/7 automated audits. Data-driven decisions.</a:t>
-            </a:r>
-          </a:p>
-        </p:txBody>
-      </p:sp>
-      <p:sp>
-        <p:nvSpPr>
-          <p:cNvPr id="36" name="TextBox 35"/>
-          <p:cNvSpPr txBox="1"/>
-          <p:nvPr/>
-        </p:nvSpPr>
-        <p:spPr>
-          <a:xfrm>
-            <a:off x="6400800" y="4160520"/>
-            <a:ext cx="1097280" cy="201168"/>
-          </a:xfrm>
-          <a:prstGeom prst="rect">
-            <a:avLst/>
-          </a:prstGeom>
-          <a:noFill/>
-        </p:spPr>
-        <p:txBody>
-          <a:bodyPr wrap="square" anchor="t"/>
-          <a:lstStyle/>
-          <a:p>
-            <a:pPr algn="r"/>
-            <a:r>
-              <a:rPr sz="1050" b="0" i="1">
-                <a:solidFill>
-                  <a:srgbClr val="38165F"/>
-                </a:solidFill>
-                <a:latin typeface="Georgia"/>
-              </a:rPr>
-              <a:t>Always-on</a:t>
-            </a:r>
-          </a:p>
-        </p:txBody>
-      </p:sp>
-      <p:sp>
-        <p:nvSpPr>
-          <p:cNvPr id="37" name="TextBox 36"/>
-          <p:cNvSpPr txBox="1"/>
-          <p:nvPr/>
-        </p:nvSpPr>
-        <p:spPr>
-          <a:xfrm>
-            <a:off x="548640" y="4416552"/>
-            <a:ext cx="914400" cy="201168"/>
-          </a:xfrm>
-          <a:prstGeom prst="rect">
-            <a:avLst/>
-          </a:prstGeom>
-          <a:noFill/>
-        </p:spPr>
-        <p:txBody>
-          <a:bodyPr wrap="square" anchor="t"/>
-          <a:lstStyle/>
-          <a:p>
-            <a:pPr algn="l"/>
-            <a:r>
-              <a:rPr sz="800" b="1" i="0">
-                <a:solidFill>
-                  <a:srgbClr val="A5A5A5"/>
-                </a:solidFill>
-                <a:latin typeface="Calibri"/>
-              </a:rPr>
-              <a:t>INTEGRATION</a:t>
-            </a:r>
-          </a:p>
-        </p:txBody>
-      </p:sp>
-      <p:sp>
-        <p:nvSpPr>
-          <p:cNvPr id="38" name="TextBox 37"/>
-          <p:cNvSpPr txBox="1"/>
-          <p:nvPr/>
-        </p:nvSpPr>
-        <p:spPr>
-          <a:xfrm>
-            <a:off x="1554480" y="4416552"/>
-            <a:ext cx="4572000" cy="201168"/>
-          </a:xfrm>
-          <a:prstGeom prst="rect">
-            <a:avLst/>
-          </a:prstGeom>
-          <a:noFill/>
-        </p:spPr>
-        <p:txBody>
-          <a:bodyPr wrap="square" anchor="t"/>
-          <a:lstStyle/>
-          <a:p>
-            <a:pPr algn="l"/>
-            <a:r>
-              <a:rPr sz="1050" b="0" i="0">
-                <a:solidFill>
-                  <a:srgbClr val="242423"/>
-                </a:solidFill>
-                <a:latin typeface="Calibri"/>
-              </a:rPr>
-              <a:t>Every system talks to every other system.</a:t>
+              <a:t>PICK ACCURACY · GORGIAS FY25</a:t>
             </a:r>
           </a:p>
         </p:txBody>
@@ -6579,74 +6580,8 @@
         </p:nvSpPr>
         <p:spPr>
           <a:xfrm>
-            <a:off x="6400800" y="4416552"/>
-            <a:ext cx="1097280" cy="201168"/>
-          </a:xfrm>
-          <a:prstGeom prst="rect">
-            <a:avLst/>
-          </a:prstGeom>
-          <a:noFill/>
-        </p:spPr>
-        <p:txBody>
-          <a:bodyPr wrap="square" anchor="t"/>
-          <a:lstStyle/>
-          <a:p>
-            <a:pPr algn="r"/>
-            <a:r>
-              <a:rPr sz="1050" b="0" i="1">
-                <a:solidFill>
-                  <a:srgbClr val="38165F"/>
-                </a:solidFill>
-                <a:latin typeface="Georgia"/>
-              </a:rPr>
-              <a:t>One graph</a:t>
-            </a:r>
-          </a:p>
-        </p:txBody>
-      </p:sp>
-      <p:sp>
-        <p:nvSpPr>
-          <p:cNvPr id="40" name="TextBox 39"/>
-          <p:cNvSpPr txBox="1"/>
-          <p:nvPr/>
-        </p:nvSpPr>
-        <p:spPr>
-          <a:xfrm>
-            <a:off x="548640" y="4846320"/>
-            <a:ext cx="4572000" cy="182880"/>
-          </a:xfrm>
-          <a:prstGeom prst="rect">
-            <a:avLst/>
-          </a:prstGeom>
-          <a:noFill/>
-        </p:spPr>
-        <p:txBody>
-          <a:bodyPr wrap="square" anchor="t"/>
-          <a:lstStyle/>
-          <a:p>
-            <a:pPr algn="l"/>
-            <a:r>
-              <a:rPr sz="900" b="1" i="0">
-                <a:solidFill>
-                  <a:srgbClr val="A5A5A5"/>
-                </a:solidFill>
-                <a:latin typeface="Calibri"/>
-              </a:rPr>
-              <a:t>PICK ACCURACY · GORGIAS FY25</a:t>
-            </a:r>
-          </a:p>
-        </p:txBody>
-      </p:sp>
-      <p:sp>
-        <p:nvSpPr>
-          <p:cNvPr id="41" name="TextBox 40"/>
-          <p:cNvSpPr txBox="1"/>
-          <p:nvPr/>
-        </p:nvSpPr>
-        <p:spPr>
-          <a:xfrm>
-            <a:off x="548640" y="5029200"/>
-            <a:ext cx="2743200" cy="640080"/>
+            <a:off x="7406640" y="3017520"/>
+            <a:ext cx="2743200" cy="731520"/>
           </a:xfrm>
           <a:prstGeom prst="rect">
             <a:avLst/>
@@ -6661,11 +6596,11 @@
           <a:p>
             <a:pPr algn="l">
               <a:lnSpc>
-                <a:spcPts val="5520"/>
+                <a:spcPts val="6439"/>
               </a:lnSpc>
             </a:pPr>
             <a:r>
-              <a:rPr sz="4800" b="0" i="0">
+              <a:rPr sz="5600" b="0" i="0">
                 <a:solidFill>
                   <a:srgbClr val="38165F"/>
                 </a:solidFill>
@@ -6674,7 +6609,7 @@
               <a:t>98.2</a:t>
             </a:r>
             <a:r>
-              <a:rPr sz="2400" b="0" i="0">
+              <a:rPr sz="2800" b="0" i="0">
                 <a:solidFill>
                   <a:srgbClr val="A5A5A5"/>
                 </a:solidFill>
@@ -6687,14 +6622,14 @@
       </p:sp>
       <p:sp>
         <p:nvSpPr>
-          <p:cNvPr id="42" name="TextBox 41"/>
-          <p:cNvSpPr txBox="1"/>
-          <p:nvPr/>
-        </p:nvSpPr>
-        <p:spPr>
-          <a:xfrm>
-            <a:off x="2560320" y="5166360"/>
-            <a:ext cx="3657600" cy="274320"/>
+          <p:cNvPr id="40" name="TextBox 39"/>
+          <p:cNvSpPr txBox="1"/>
+          <p:nvPr/>
+        </p:nvSpPr>
+        <p:spPr>
+          <a:xfrm>
+            <a:off x="7406640" y="3749039"/>
+            <a:ext cx="4023360" cy="274320"/>
           </a:xfrm>
           <a:prstGeom prst="rect">
             <a:avLst/>
@@ -6713,21 +6648,22 @@
                 </a:solidFill>
                 <a:latin typeface="Calibri"/>
               </a:rPr>
-              <a:t>OF SHIPPED ORDERS — NO CUSTOMER-REPORTED ISSUE</a:t>
-            </a:r>
-          </a:p>
-        </p:txBody>
-      </p:sp>
-      <p:sp>
-        <p:nvSpPr>
-          <p:cNvPr id="43" name="Rectangle 42"/>
+              <a:t>OF SHIPPED ORDERS —
+NO CUSTOMER-REPORTED ISSUE</a:t>
+            </a:r>
+          </a:p>
+        </p:txBody>
+      </p:sp>
+      <p:sp>
+        <p:nvSpPr>
+          <p:cNvPr id="41" name="Rectangle 40"/>
           <p:cNvSpPr/>
           <p:nvPr/>
         </p:nvSpPr>
         <p:spPr>
           <a:xfrm>
-            <a:off x="548640" y="5852160"/>
-            <a:ext cx="25400" cy="548640"/>
+            <a:off x="7406640" y="4251960"/>
+            <a:ext cx="25400" cy="1645920"/>
           </a:xfrm>
           <a:prstGeom prst="rect">
             <a:avLst/>
@@ -6763,14 +6699,14 @@
       </p:sp>
       <p:sp>
         <p:nvSpPr>
-          <p:cNvPr id="44" name="TextBox 43"/>
-          <p:cNvSpPr txBox="1"/>
-          <p:nvPr/>
-        </p:nvSpPr>
-        <p:spPr>
-          <a:xfrm>
-            <a:off x="685800" y="5870448"/>
-            <a:ext cx="10515600" cy="548640"/>
+          <p:cNvPr id="42" name="TextBox 41"/>
+          <p:cNvSpPr txBox="1"/>
+          <p:nvPr/>
+        </p:nvSpPr>
+        <p:spPr>
+          <a:xfrm>
+            <a:off x="7543800" y="4297680"/>
+            <a:ext cx="3840480" cy="1554480"/>
           </a:xfrm>
           <a:prstGeom prst="rect">
             <a:avLst/>
@@ -6785,11 +6721,11 @@
           <a:p>
             <a:pPr algn="l">
               <a:lnSpc>
-                <a:spcPts val="1207"/>
+                <a:spcPts val="1264"/>
               </a:lnSpc>
             </a:pPr>
             <a:r>
-              <a:rPr sz="1050" b="1" i="0">
+              <a:rPr sz="1100" b="1" i="0">
                 <a:solidFill>
                   <a:srgbClr val="242423"/>
                 </a:solidFill>
@@ -6798,13 +6734,13 @@
               <a:t>Held the line during the rebuild. </a:t>
             </a:r>
             <a:r>
-              <a:rPr sz="1050" b="0" i="1">
+              <a:rPr sz="1100" b="0" i="1">
                 <a:solidFill>
                   <a:srgbClr val="242423"/>
                 </a:solidFill>
                 <a:latin typeface="Georgia"/>
               </a:rPr>
-              <a:t>Q4 2025 — the quarter we re-sequenced the pick line — shipped record holiday volume (Dec 2025: 61,503 shipments, peak 5,268/day) without degrading the accuracy floor.</a:t>
+              <a:t>Q4 2025 — the quarter we re-sequenced the pick line — shipped record holiday volume (Dec 2025: 61,503 shipments) without degrading the accuracy floor.</a:t>
             </a:r>
           </a:p>
         </p:txBody>

</xml_diff>

<commit_message>
v9.6: fix table header fill and stat label clipping
- Kill PowerPoint default table style (removes colored first-row fill,
  banding, and all auto-formatting) via tblPr attribute clearing
- Increase stat label text box height (0.3" -> 0.45") to prevent clipping
  on two-line labels like "DAILY CAPACITY\nPEAK (2023)"

Co-Authored-By: Claude Opus 4.6 (1M context) <noreply@anthropic.com>
</commit_message>
<xml_diff>
--- a/brand.pptx
+++ b/brand.pptx
@@ -3480,7 +3480,7 @@
         <a:graphic>
           <a:graphicData uri="http://schemas.openxmlformats.org/drawingml/2006/table">
             <a:tbl>
-              <a:tblPr firstRow="1" bandRow="1">
+              <a:tblPr firstRow="0" bandRow="0" bandCol="0" firstCol="0" lastRow="0" lastCol="0">
                 <a:tableStyleId>{5C22544A-7EE6-4342-B048-85BDC9FD1C3A}</a:tableStyleId>
               </a:tblPr>
               <a:tblGrid>
@@ -4074,8 +4074,8 @@
         </p:nvSpPr>
         <p:spPr>
           <a:xfrm>
-            <a:off x="685800" y="5038344"/>
-            <a:ext cx="1554480" cy="274320"/>
+            <a:off x="685800" y="5056632"/>
+            <a:ext cx="1554480" cy="411480"/>
           </a:xfrm>
           <a:prstGeom prst="rect">
             <a:avLst/>
@@ -4145,8 +4145,8 @@
         </p:nvSpPr>
         <p:spPr>
           <a:xfrm>
-            <a:off x="2377440" y="5038344"/>
-            <a:ext cx="1554480" cy="274320"/>
+            <a:off x="2377440" y="5056632"/>
+            <a:ext cx="1554480" cy="411480"/>
           </a:xfrm>
           <a:prstGeom prst="rect">
             <a:avLst/>
@@ -4216,8 +4216,8 @@
         </p:nvSpPr>
         <p:spPr>
           <a:xfrm>
-            <a:off x="4114800" y="5038344"/>
-            <a:ext cx="1554480" cy="274320"/>
+            <a:off x="4114800" y="5056632"/>
+            <a:ext cx="1554480" cy="411480"/>
           </a:xfrm>
           <a:prstGeom prst="rect">
             <a:avLst/>
@@ -4416,7 +4416,7 @@
         <a:graphic>
           <a:graphicData uri="http://schemas.openxmlformats.org/drawingml/2006/table">
             <a:tbl>
-              <a:tblPr firstRow="1" bandRow="1">
+              <a:tblPr firstRow="0" bandRow="0" bandCol="0" firstCol="0" lastRow="0" lastCol="0">
                 <a:tableStyleId>{5C22544A-7EE6-4342-B048-85BDC9FD1C3A}</a:tableStyleId>
               </a:tblPr>
               <a:tblGrid>
@@ -5195,8 +5195,8 @@
         </p:nvSpPr>
         <p:spPr>
           <a:xfrm>
-            <a:off x="6446520" y="5038344"/>
-            <a:ext cx="1554480" cy="274320"/>
+            <a:off x="6446520" y="5056632"/>
+            <a:ext cx="1554480" cy="411480"/>
           </a:xfrm>
           <a:prstGeom prst="rect">
             <a:avLst/>
@@ -5266,8 +5266,8 @@
         </p:nvSpPr>
         <p:spPr>
           <a:xfrm>
-            <a:off x="8183880" y="5038344"/>
-            <a:ext cx="1554480" cy="274320"/>
+            <a:off x="8183880" y="5056632"/>
+            <a:ext cx="1554480" cy="411480"/>
           </a:xfrm>
           <a:prstGeom prst="rect">
             <a:avLst/>
@@ -5337,8 +5337,8 @@
         </p:nvSpPr>
         <p:spPr>
           <a:xfrm>
-            <a:off x="10012680" y="5038344"/>
-            <a:ext cx="1554480" cy="274320"/>
+            <a:off x="10012680" y="5056632"/>
+            <a:ext cx="1554480" cy="411480"/>
           </a:xfrm>
           <a:prstGeom prst="rect">
             <a:avLst/>
@@ -5984,7 +5984,7 @@
         <a:graphic>
           <a:graphicData uri="http://schemas.openxmlformats.org/drawingml/2006/table">
             <a:tbl>
-              <a:tblPr firstRow="1" bandRow="1">
+              <a:tblPr firstRow="0" bandRow="0" bandCol="0" firstCol="0" lastRow="0" lastCol="0">
                 <a:tableStyleId>{5C22544A-7EE6-4342-B048-85BDC9FD1C3A}</a:tableStyleId>
               </a:tblPr>
               <a:tblGrid>
@@ -7029,7 +7029,7 @@
         <a:graphic>
           <a:graphicData uri="http://schemas.openxmlformats.org/drawingml/2006/table">
             <a:tbl>
-              <a:tblPr firstRow="1" bandRow="1">
+              <a:tblPr firstRow="0" bandRow="0" bandCol="0" firstCol="0" lastRow="0" lastCol="0">
                 <a:tableStyleId>{5C22544A-7EE6-4342-B048-85BDC9FD1C3A}</a:tableStyleId>
               </a:tblPr>
               <a:tblGrid>
@@ -8862,7 +8862,7 @@
         <a:graphic>
           <a:graphicData uri="http://schemas.openxmlformats.org/drawingml/2006/table">
             <a:tbl>
-              <a:tblPr firstRow="1" bandRow="1">
+              <a:tblPr firstRow="0" bandRow="0" bandCol="0" firstCol="0" lastRow="0" lastCol="0">
                 <a:tableStyleId>{5C22544A-7EE6-4342-B048-85BDC9FD1C3A}</a:tableStyleId>
               </a:tblPr>
               <a:tblGrid>
@@ -9702,7 +9702,7 @@
         <a:graphic>
           <a:graphicData uri="http://schemas.openxmlformats.org/drawingml/2006/table">
             <a:tbl>
-              <a:tblPr firstRow="1" bandRow="1">
+              <a:tblPr firstRow="0" bandRow="0" bandCol="0" firstCol="0" lastRow="0" lastCol="0">
                 <a:tableStyleId>{5C22544A-7EE6-4342-B048-85BDC9FD1C3A}</a:tableStyleId>
               </a:tblPr>
               <a:tblGrid>

</xml_diff>